<commit_message>
added annexes, need a last review
</commit_message>
<xml_diff>
--- a/RAPPORT/TB_affiche_Nathan_Tschantz.pptx
+++ b/RAPPORT/TB_affiche_Nathan_Tschantz.pptx
@@ -197,7 +197,7 @@
           <a:p>
             <a:fld id="{18A9F4A2-E97A-F248-AE61-52986AC63982}" type="datetimeFigureOut">
               <a:rPr lang="fr-CH" smtClean="0"/>
-              <a:t>19.07.2026</a:t>
+              <a:t>20.07.2026</a:t>
             </a:fld>
             <a:endParaRPr lang="fr-CH"/>
           </a:p>
@@ -680,7 +680,7 @@
           <a:p>
             <a:fld id="{4F500F00-1D35-254B-9117-3FE363B8C978}" type="datetimeFigureOut">
               <a:rPr lang="fr-CH" smtClean="0"/>
-              <a:t>19.07.2026</a:t>
+              <a:t>20.07.2026</a:t>
             </a:fld>
             <a:endParaRPr lang="fr-CH"/>
           </a:p>
@@ -850,7 +850,7 @@
           <a:p>
             <a:fld id="{4F500F00-1D35-254B-9117-3FE363B8C978}" type="datetimeFigureOut">
               <a:rPr lang="fr-CH" smtClean="0"/>
-              <a:t>19.07.2026</a:t>
+              <a:t>20.07.2026</a:t>
             </a:fld>
             <a:endParaRPr lang="fr-CH"/>
           </a:p>
@@ -1030,7 +1030,7 @@
           <a:p>
             <a:fld id="{4F500F00-1D35-254B-9117-3FE363B8C978}" type="datetimeFigureOut">
               <a:rPr lang="fr-CH" smtClean="0"/>
-              <a:t>19.07.2026</a:t>
+              <a:t>20.07.2026</a:t>
             </a:fld>
             <a:endParaRPr lang="fr-CH"/>
           </a:p>
@@ -1200,7 +1200,7 @@
           <a:p>
             <a:fld id="{4F500F00-1D35-254B-9117-3FE363B8C978}" type="datetimeFigureOut">
               <a:rPr lang="fr-CH" smtClean="0"/>
-              <a:t>19.07.2026</a:t>
+              <a:t>20.07.2026</a:t>
             </a:fld>
             <a:endParaRPr lang="fr-CH"/>
           </a:p>
@@ -1446,7 +1446,7 @@
           <a:p>
             <a:fld id="{4F500F00-1D35-254B-9117-3FE363B8C978}" type="datetimeFigureOut">
               <a:rPr lang="fr-CH" smtClean="0"/>
-              <a:t>19.07.2026</a:t>
+              <a:t>20.07.2026</a:t>
             </a:fld>
             <a:endParaRPr lang="fr-CH"/>
           </a:p>
@@ -1678,7 +1678,7 @@
           <a:p>
             <a:fld id="{4F500F00-1D35-254B-9117-3FE363B8C978}" type="datetimeFigureOut">
               <a:rPr lang="fr-CH" smtClean="0"/>
-              <a:t>19.07.2026</a:t>
+              <a:t>20.07.2026</a:t>
             </a:fld>
             <a:endParaRPr lang="fr-CH"/>
           </a:p>
@@ -2045,7 +2045,7 @@
           <a:p>
             <a:fld id="{4F500F00-1D35-254B-9117-3FE363B8C978}" type="datetimeFigureOut">
               <a:rPr lang="fr-CH" smtClean="0"/>
-              <a:t>19.07.2026</a:t>
+              <a:t>20.07.2026</a:t>
             </a:fld>
             <a:endParaRPr lang="fr-CH"/>
           </a:p>
@@ -2163,7 +2163,7 @@
           <a:p>
             <a:fld id="{4F500F00-1D35-254B-9117-3FE363B8C978}" type="datetimeFigureOut">
               <a:rPr lang="fr-CH" smtClean="0"/>
-              <a:t>19.07.2026</a:t>
+              <a:t>20.07.2026</a:t>
             </a:fld>
             <a:endParaRPr lang="fr-CH"/>
           </a:p>
@@ -2258,7 +2258,7 @@
           <a:p>
             <a:fld id="{4F500F00-1D35-254B-9117-3FE363B8C978}" type="datetimeFigureOut">
               <a:rPr lang="fr-CH" smtClean="0"/>
-              <a:t>19.07.2026</a:t>
+              <a:t>20.07.2026</a:t>
             </a:fld>
             <a:endParaRPr lang="fr-CH"/>
           </a:p>
@@ -2535,7 +2535,7 @@
           <a:p>
             <a:fld id="{4F500F00-1D35-254B-9117-3FE363B8C978}" type="datetimeFigureOut">
               <a:rPr lang="fr-CH" smtClean="0"/>
-              <a:t>19.07.2026</a:t>
+              <a:t>20.07.2026</a:t>
             </a:fld>
             <a:endParaRPr lang="fr-CH"/>
           </a:p>
@@ -2792,7 +2792,7 @@
           <a:p>
             <a:fld id="{4F500F00-1D35-254B-9117-3FE363B8C978}" type="datetimeFigureOut">
               <a:rPr lang="fr-CH" smtClean="0"/>
-              <a:t>19.07.2026</a:t>
+              <a:t>20.07.2026</a:t>
             </a:fld>
             <a:endParaRPr lang="fr-CH"/>
           </a:p>
@@ -3005,7 +3005,7 @@
           <a:p>
             <a:fld id="{4F500F00-1D35-254B-9117-3FE363B8C978}" type="datetimeFigureOut">
               <a:rPr lang="fr-CH" smtClean="0"/>
-              <a:t>19.07.2026</a:t>
+              <a:t>20.07.2026</a:t>
             </a:fld>
             <a:endParaRPr lang="fr-CH"/>
           </a:p>
@@ -3504,6 +3504,7 @@
             </a:endParaRPr>
           </a:p>
           <a:p>
+            <a:pPr algn="just"/>
             <a:r>
               <a:rPr lang="fr-FR" sz="1400" dirty="0">
                 <a:latin typeface="Arial" panose="020B0604020202020204" pitchFamily="34" charset="0"/>
@@ -3520,15 +3521,7 @@
               <a:rPr lang="fr-FR" sz="1400" dirty="0">
                 <a:latin typeface="Arial" panose="020B0604020202020204" pitchFamily="34" charset="0"/>
               </a:rPr>
-              <a:t>. L'enjeu réside dans le contournement des lourdes contraintes temporelles des protocoles réseau classiques. Le projet cible une optimisation agressive de la chaîne d'acquisition avec l’implémentation d'un pipeline de compression exclusivement intra-frame (MJPEG). Développement d'une passerelle en C pour le découpage des images à la volée.</a:t>
-            </a:r>
-          </a:p>
-          <a:p>
-            <a:r>
-              <a:rPr lang="fr-FR" sz="1400" dirty="0">
-                <a:latin typeface="Arial" panose="020B0604020202020204" pitchFamily="34" charset="0"/>
-              </a:rPr>
-              <a:t>Forçage matériel de la Qualité de Service (QoS/EDCA) au niveau de la couche MAC. Isolation et overclocking du processeur embarqué. Le but est de stabiliser le flux sous le seuil de viabilité fixé à 80 ms pour garantir un pilotage sûr.</a:t>
+              <a:t>. L'enjeu réside dans le contournement des lourdes contraintes temporelles des protocoles réseau classiques. Le projet cible une optimisation de la chaîne d'acquisition avec l’implémentation d'un pipeline de compression exclusivement intra-frame (MJPEG). Le système comporte le développement d'une passerelle en C pour le découpage des images à la volée, le forçage matériel de la Qualité de Service (QoS/EDCA) au niveau de la couche MAC, l’isolation d’un cœur et l’overclocking du processeur embarqué. Le but est de stabiliser le flux sous le seuil de viabilité fixé à 80 ms pour garantir un pilotage sûr.</a:t>
             </a:r>
             <a:endParaRPr lang="fr-CH" sz="1400" dirty="0">
               <a:latin typeface="Arial" panose="020B0604020202020204" pitchFamily="34" charset="0"/>
@@ -3586,7 +3579,7 @@
                 <a:latin typeface="Arial" panose="020B0604020202020204" pitchFamily="34" charset="0"/>
                 <a:cs typeface="Arial" panose="020B0604020202020204" pitchFamily="34" charset="0"/>
               </a:rPr>
-              <a:t>Le développement sur l'écosystème Raspberry Pi et STM32 a permis d'éliminer les buffers de rétention réseau en configurant la liaison en UDP Unicast (MCS 1, canal 8 MHz) et en désactivant la veille de la puce radio (PSM). Le transport matériel pur (transfert SPI, encapsulation et vol RF) s'effectue en seulement 12.5 ms. L'analyse statistique de 79 échantillons réels (capturés à 240 FPS sur un affichage à 165 Hz) démontre une stabilité remarquable du flux vidéo (320x240 @ 60 FPS). La latence globale moyenne est de 40.1 ms (gigue = 6.4 ms). Des pics bas sont observé a 25 ms et des Pic haut isolé de 60 ms. Lors des essais de portée dans les locaux de l'IICT, le retour vidéo est resté recevable à travers deux étages du bâtiment.</a:t>
+              <a:t>Le développement sur l'écosystème Raspberry Pi et STM32 a permis d'éliminer les buffers de rétention réseau en configurant la liaison en UDP Unicast (MCS 1, canal 8 MHz) et en désactivant la veille de la puce radio (PSM). Le transport matériel pur (transfert SPI, encapsulation et vol RF) s'effectue en seulement 12.5 ms. L'analyse statistique de 79 échantillons réels (capturés à 240 FPS sur un affichage à 165 Hz) démontre une stabilité remarquable du flux vidéo (320x240, 60 FPS). La latence globale moyenne est de 40.1 ms (gigue = 6.4 ms). Des pics bas sont observé a 25 ms et des Pic haut isolé de 60 ms. Lors des essais de portée dans les locaux de l'IICT, le retour vidéo est resté recevable à travers deux étages du bâtiment avec une puissance d’émission faible de 14dbm.</a:t>
             </a:r>
             <a:br>
               <a:rPr lang="fr-CH" sz="1400" dirty="0">
@@ -3640,7 +3633,7 @@
                 <a:latin typeface="Arial" panose="020B0604020202020204" pitchFamily="34" charset="0"/>
                 <a:cs typeface="Arial" panose="020B0604020202020204" pitchFamily="34" charset="0"/>
               </a:rPr>
-              <a:t> pour la transmission vidéo en temps réel. En repensant l'intégralité de la pile logicielle, le prototype démontre qu'il est possible de combiner la robustesse physique permise par les basses fréquences avec la réactivité du FPV. En dépassant les objectifs initiaux, cette architecture ouvre de nouvelles perspectives pour l'exploration robotique et le sauvetage en milieux confinés et hautement obstrués.</a:t>
+              <a:t> pour la transmission vidéo en temps réel. En optimisant l'intégralité de la pile logicielle, le prototype démontre qu'il est possible de combiner la robustesse physique permise par les basses fréquences avec la réactivité du FPV. En dépassant les objectifs initiaux, cette architecture ouvre de nouvelles perspectives pour l'exploration robotique et le sauvetage en milieux confinés et hautement obstrués.</a:t>
             </a:r>
             <a:endParaRPr lang="fr-CH" sz="1400" dirty="0">
               <a:effectLst/>
@@ -4798,12 +4791,12 @@
 </file>
 
 <file path=customXml/item1.xml><?xml version="1.0" encoding="utf-8"?>
-<?mso-contentType ?>
-<FormTemplates xmlns="http://schemas.microsoft.com/sharepoint/v3/contenttype/forms">
-  <Display>DocumentLibraryForm</Display>
-  <Edit>DocumentLibraryForm</Edit>
-  <New>DocumentLibraryForm</New>
-</FormTemplates>
+<p:properties xmlns:p="http://schemas.microsoft.com/office/2006/metadata/properties" xmlns:xsi="http://www.w3.org/2001/XMLSchema-instance" xmlns:pc="http://schemas.microsoft.com/office/infopath/2007/PartnerControls">
+  <documentManagement>
+    <PublishingExpirationDate xmlns="http://schemas.microsoft.com/sharepoint/v3" xsi:nil="true"/>
+    <PublishingStartDate xmlns="http://schemas.microsoft.com/sharepoint/v3" xsi:nil="true"/>
+  </documentManagement>
+</p:properties>
 </file>
 
 <file path=customXml/item2.xml><?xml version="1.0" encoding="utf-8"?>
@@ -4939,18 +4932,20 @@
 </file>
 
 <file path=customXml/item3.xml><?xml version="1.0" encoding="utf-8"?>
-<p:properties xmlns:p="http://schemas.microsoft.com/office/2006/metadata/properties" xmlns:xsi="http://www.w3.org/2001/XMLSchema-instance" xmlns:pc="http://schemas.microsoft.com/office/infopath/2007/PartnerControls">
-  <documentManagement>
-    <PublishingExpirationDate xmlns="http://schemas.microsoft.com/sharepoint/v3" xsi:nil="true"/>
-    <PublishingStartDate xmlns="http://schemas.microsoft.com/sharepoint/v3" xsi:nil="true"/>
-  </documentManagement>
-</p:properties>
+<?mso-contentType ?>
+<FormTemplates xmlns="http://schemas.microsoft.com/sharepoint/v3/contenttype/forms">
+  <Display>DocumentLibraryForm</Display>
+  <Edit>DocumentLibraryForm</Edit>
+  <New>DocumentLibraryForm</New>
+</FormTemplates>
 </file>
 
 <file path=customXml/itemProps1.xml><?xml version="1.0" encoding="utf-8"?>
-<ds:datastoreItem xmlns:ds="http://schemas.openxmlformats.org/officeDocument/2006/customXml" ds:itemID="{3FAAD471-60E3-4269-8F77-1FB8D65951AF}">
+<ds:datastoreItem xmlns:ds="http://schemas.openxmlformats.org/officeDocument/2006/customXml" ds:itemID="{78925618-3156-4746-8B68-5C33F2AB0FD4}">
   <ds:schemaRefs>
-    <ds:schemaRef ds:uri="http://schemas.microsoft.com/sharepoint/v3/contenttype/forms"/>
+    <ds:schemaRef ds:uri="http://schemas.microsoft.com/office/2006/metadata/properties"/>
+    <ds:schemaRef ds:uri="http://schemas.microsoft.com/office/infopath/2007/PartnerControls"/>
+    <ds:schemaRef ds:uri="http://schemas.microsoft.com/sharepoint/v3"/>
   </ds:schemaRefs>
 </ds:datastoreItem>
 </file>
@@ -4974,11 +4969,9 @@
 </file>
 
 <file path=customXml/itemProps3.xml><?xml version="1.0" encoding="utf-8"?>
-<ds:datastoreItem xmlns:ds="http://schemas.openxmlformats.org/officeDocument/2006/customXml" ds:itemID="{78925618-3156-4746-8B68-5C33F2AB0FD4}">
+<ds:datastoreItem xmlns:ds="http://schemas.openxmlformats.org/officeDocument/2006/customXml" ds:itemID="{3FAAD471-60E3-4269-8F77-1FB8D65951AF}">
   <ds:schemaRefs>
-    <ds:schemaRef ds:uri="http://schemas.microsoft.com/office/2006/metadata/properties"/>
-    <ds:schemaRef ds:uri="http://schemas.microsoft.com/office/infopath/2007/PartnerControls"/>
-    <ds:schemaRef ds:uri="http://schemas.microsoft.com/sharepoint/v3"/>
+    <ds:schemaRef ds:uri="http://schemas.microsoft.com/sharepoint/v3/contenttype/forms"/>
   </ds:schemaRefs>
 </ds:datastoreItem>
 </file>
</xml_diff>